<commit_message>
Presentaciones de sintesis de los modulos 05-10; ajuste de titulos en 01-04
</commit_message>
<xml_diff>
--- a/_entregables/presentaciones/Modulo01_sintesis.pptx
+++ b/_entregables/presentaciones/Modulo01_sintesis.pptx
@@ -2497,7 +2497,7 @@
         <p:spPr>
           <a:xfrm>
             <a:off x="685800" y="1417320"/>
-            <a:ext cx="2133600" cy="822960"/>
+            <a:ext cx="2133600" cy="868680"/>
           </a:xfrm>
           <a:prstGeom prst="rect">
             <a:avLst/>
@@ -2513,7 +2513,7 @@
               <a:buNone/>
             </a:pPr>
             <a:r>
-              <a:rPr lang="en-US" sz="2200" b="1" dirty="0">
+              <a:rPr lang="en-US" sz="1700" b="1" dirty="0">
                 <a:solidFill>
                   <a:srgbClr val="0B3C49"/>
                 </a:solidFill>
@@ -2523,7 +2523,7 @@
               </a:rPr>
               <a:t>Diversificación de la dieta</a:t>
             </a:r>
-            <a:endParaRPr lang="en-US" sz="2200" dirty="0"/>
+            <a:endParaRPr lang="en-US" sz="1700" dirty="0"/>
           </a:p>
         </p:txBody>
       </p:sp>
@@ -2535,8 +2535,8 @@
         </p:nvSpPr>
         <p:spPr>
           <a:xfrm>
-            <a:off x="685800" y="2286000"/>
-            <a:ext cx="2133600" cy="1920240"/>
+            <a:off x="685800" y="2423160"/>
+            <a:ext cx="2133600" cy="1783080"/>
           </a:xfrm>
           <a:prstGeom prst="rect">
             <a:avLst/>
@@ -2600,7 +2600,7 @@
         <p:spPr>
           <a:xfrm>
             <a:off x="3505200" y="1417320"/>
-            <a:ext cx="2133600" cy="822960"/>
+            <a:ext cx="2133600" cy="868680"/>
           </a:xfrm>
           <a:prstGeom prst="rect">
             <a:avLst/>
@@ -2638,8 +2638,8 @@
         </p:nvSpPr>
         <p:spPr>
           <a:xfrm>
-            <a:off x="3505200" y="2286000"/>
-            <a:ext cx="2133600" cy="1920240"/>
+            <a:off x="3505200" y="2423160"/>
+            <a:ext cx="2133600" cy="1783080"/>
           </a:xfrm>
           <a:prstGeom prst="rect">
             <a:avLst/>
@@ -2703,7 +2703,7 @@
         <p:spPr>
           <a:xfrm>
             <a:off x="6324600" y="1417320"/>
-            <a:ext cx="2133600" cy="822960"/>
+            <a:ext cx="2133600" cy="868680"/>
           </a:xfrm>
           <a:prstGeom prst="rect">
             <a:avLst/>
@@ -2741,8 +2741,8 @@
         </p:nvSpPr>
         <p:spPr>
           <a:xfrm>
-            <a:off x="6324600" y="2286000"/>
-            <a:ext cx="2133600" cy="1920240"/>
+            <a:off x="6324600" y="2423160"/>
+            <a:ext cx="2133600" cy="1783080"/>
           </a:xfrm>
           <a:prstGeom prst="rect">
             <a:avLst/>

</xml_diff>